<commit_message>
adds initial template for last half of devops lessons
</commit_message>
<xml_diff>
--- a/DevOps/Lesson 01 - Intro to Version Control/Intro to Version Control.pptx
+++ b/DevOps/Lesson 01 - Intro to Version Control/Intro to Version Control.pptx
@@ -4255,7 +4255,7 @@
           <a:p>
             <a:fld id="{7A3E0868-4E26-4CDC-8A56-D70E2D8B12FE}" type="datetime3">
               <a:rPr lang="en-US" smtClean="0"/>
-              <a:t>28 May 2026</a:t>
+              <a:t>4 June 2026</a:t>
             </a:fld>
             <a:endParaRPr lang="en-US"/>
           </a:p>
@@ -6816,7 +6816,7 @@
           <a:p>
             <a:fld id="{A7B8021B-6105-4216-96FC-94348F216D0E}" type="datetime3">
               <a:rPr lang="en-US" smtClean="0"/>
-              <a:t>28 May 2026</a:t>
+              <a:t>4 June 2026</a:t>
             </a:fld>
             <a:endParaRPr lang="en-US"/>
           </a:p>
@@ -8513,7 +8513,7 @@
           <a:p>
             <a:fld id="{5D27CFAB-73E6-44A8-B862-B3306344E3F2}" type="datetime3">
               <a:rPr lang="en-US" smtClean="0"/>
-              <a:t>28 May 2026</a:t>
+              <a:t>4 June 2026</a:t>
             </a:fld>
             <a:endParaRPr lang="en-US"/>
           </a:p>
@@ -10303,7 +10303,7 @@
           <a:p>
             <a:fld id="{A9B2E784-A5F5-4301-881B-94AC8DBF9DED}" type="datetime3">
               <a:rPr lang="en-US" smtClean="0"/>
-              <a:t>28 May 2026</a:t>
+              <a:t>4 June 2026</a:t>
             </a:fld>
             <a:endParaRPr lang="en-US"/>
           </a:p>
@@ -10482,7 +10482,7 @@
           <a:p>
             <a:fld id="{18EAB3A5-9E92-4BB9-8F22-9632B4FBEDBA}" type="datetime3">
               <a:rPr lang="en-US" smtClean="0"/>
-              <a:t>28 May 2026</a:t>
+              <a:t>4 June 2026</a:t>
             </a:fld>
             <a:endParaRPr lang="en-US"/>
           </a:p>
@@ -10709,7 +10709,7 @@
           <a:p>
             <a:fld id="{40923810-5FB2-48C9-96CA-1DE2C4773142}" type="datetime3">
               <a:rPr lang="en-US" smtClean="0"/>
-              <a:t>28 May 2026</a:t>
+              <a:t>4 June 2026</a:t>
             </a:fld>
             <a:endParaRPr lang="en-US"/>
           </a:p>
@@ -10999,7 +10999,7 @@
           <a:p>
             <a:fld id="{E50EFF4B-86EB-42FB-93EA-7D8F9CB2466F}" type="datetime3">
               <a:rPr lang="en-US" smtClean="0"/>
-              <a:t>28 May 2026</a:t>
+              <a:t>4 June 2026</a:t>
             </a:fld>
             <a:endParaRPr lang="en-US"/>
           </a:p>
@@ -11611,7 +11611,7 @@
           <a:p>
             <a:fld id="{FB14FC24-E041-45E9-9A72-E5755A86890F}" type="datetime3">
               <a:rPr lang="en-US" smtClean="0"/>
-              <a:t>28 May 2026</a:t>
+              <a:t>4 June 2026</a:t>
             </a:fld>
             <a:endParaRPr lang="en-US"/>
           </a:p>
@@ -12471,7 +12471,7 @@
           <a:p>
             <a:fld id="{98A19125-94A7-4474-858C-FD9C4ABE9DDA}" type="datetime3">
               <a:rPr lang="en-US" smtClean="0"/>
-              <a:t>28 May 2026</a:t>
+              <a:t>4 June 2026</a:t>
             </a:fld>
             <a:endParaRPr lang="en-US"/>
           </a:p>
@@ -13574,7 +13574,7 @@
           <a:p>
             <a:fld id="{3BA0343D-C8D8-43CE-BB79-50DEA219DB07}" type="datetime3">
               <a:rPr lang="en-US" smtClean="0"/>
-              <a:t>28 May 2026</a:t>
+              <a:t>4 June 2026</a:t>
             </a:fld>
             <a:endParaRPr lang="en-US"/>
           </a:p>
@@ -13863,7 +13863,7 @@
           <a:p>
             <a:fld id="{453BD212-0B9F-4987-965F-AC83B2FC354F}" type="datetime3">
               <a:rPr lang="en-US" smtClean="0"/>
-              <a:t>28 May 2026</a:t>
+              <a:t>4 June 2026</a:t>
             </a:fld>
             <a:endParaRPr lang="en-US"/>
           </a:p>
@@ -14108,7 +14108,7 @@
           <a:p>
             <a:fld id="{6DDC931E-8CBE-4A3F-A034-9B6122C6DCDB}" type="datetime3">
               <a:rPr lang="en-US" smtClean="0"/>
-              <a:t>28 May 2026</a:t>
+              <a:t>4 June 2026</a:t>
             </a:fld>
             <a:endParaRPr lang="en-US"/>
           </a:p>
@@ -15874,7 +15874,7 @@
           <a:p>
             <a:fld id="{220AF9C2-5E8A-4308-AE6B-CA9B65007D0E}" type="datetime3">
               <a:rPr lang="en-US" smtClean="0"/>
-              <a:t>28 May 2026</a:t>
+              <a:t>4 June 2026</a:t>
             </a:fld>
             <a:endParaRPr lang="en-US"/>
           </a:p>
@@ -16187,7 +16187,7 @@
           <a:p>
             <a:fld id="{FF31E861-D2AF-431D-860B-DCF67C218052}" type="datetime3">
               <a:rPr lang="en-US" smtClean="0"/>
-              <a:t>28 May 2026</a:t>
+              <a:t>4 June 2026</a:t>
             </a:fld>
             <a:endParaRPr lang="en-US"/>
           </a:p>
@@ -16466,7 +16466,7 @@
           <a:p>
             <a:fld id="{D1DA25B2-AAF1-4C1F-AA38-12D5BFA7D4C8}" type="datetime3">
               <a:rPr lang="en-US" smtClean="0"/>
-              <a:t>28 May 2026</a:t>
+              <a:t>4 June 2026</a:t>
             </a:fld>
             <a:endParaRPr lang="en-US"/>
           </a:p>
@@ -16745,7 +16745,7 @@
           <a:p>
             <a:fld id="{A25C0F39-45D0-48E9-90B3-7FE8FCE561C8}" type="datetime3">
               <a:rPr lang="en-US" smtClean="0"/>
-              <a:t>28 May 2026</a:t>
+              <a:t>4 June 2026</a:t>
             </a:fld>
             <a:endParaRPr lang="en-US"/>
           </a:p>
@@ -17246,7 +17246,7 @@
           <a:p>
             <a:fld id="{9BAF1A3D-92FA-4F24-9781-74AFA516A230}" type="datetime3">
               <a:rPr lang="en-US" smtClean="0"/>
-              <a:t>28 May 2026</a:t>
+              <a:t>4 June 2026</a:t>
             </a:fld>
             <a:endParaRPr lang="en-US"/>
           </a:p>
@@ -17373,7 +17373,7 @@
           <a:p>
             <a:fld id="{5719C672-856D-4617-A693-8FE15749A9B7}" type="datetime3">
               <a:rPr lang="en-US" smtClean="0"/>
-              <a:t>28 May 2026</a:t>
+              <a:t>4 June 2026</a:t>
             </a:fld>
             <a:endParaRPr lang="en-US"/>
           </a:p>
@@ -17508,7 +17508,7 @@
           <a:p>
             <a:fld id="{5F6C764D-A39E-4C03-B161-E0BC66E8883B}" type="datetime3">
               <a:rPr lang="en-US" smtClean="0"/>
-              <a:t>28 May 2026</a:t>
+              <a:t>4 June 2026</a:t>
             </a:fld>
             <a:endParaRPr lang="en-US"/>
           </a:p>
@@ -17750,7 +17750,7 @@
           <a:p>
             <a:fld id="{6E3E33F9-20B7-4995-BE7D-165DBB597850}" type="datetime3">
               <a:rPr lang="en-US" smtClean="0"/>
-              <a:t>28 May 2026</a:t>
+              <a:t>4 June 2026</a:t>
             </a:fld>
             <a:endParaRPr lang="en-US"/>
           </a:p>
@@ -17863,7 +17863,7 @@
           <a:p>
             <a:fld id="{CD41C263-3501-4369-A962-62B6BF915CDE}" type="datetime3">
               <a:rPr lang="en-US" smtClean="0"/>
-              <a:t>28 May 2026</a:t>
+              <a:t>4 June 2026</a:t>
             </a:fld>
             <a:endParaRPr lang="en-US"/>
           </a:p>
@@ -18266,7 +18266,7 @@
           <a:p>
             <a:fld id="{B06F3EBE-B2E8-4992-9F00-9E4B44F057C0}" type="datetime3">
               <a:rPr lang="en-US" smtClean="0"/>
-              <a:t>28 May 2026</a:t>
+              <a:t>4 June 2026</a:t>
             </a:fld>
             <a:endParaRPr lang="en-US"/>
           </a:p>
@@ -18398,7 +18398,7 @@
           <a:p>
             <a:fld id="{D41656AB-D2E1-472E-8B95-0DF5C6E1D623}" type="datetime3">
               <a:rPr lang="en-US" smtClean="0"/>
-              <a:t>28 May 2026</a:t>
+              <a:t>4 June 2026</a:t>
             </a:fld>
             <a:endParaRPr lang="en-US"/>
           </a:p>
@@ -25647,7 +25647,7 @@
           <a:p>
             <a:fld id="{AD622D1A-DF83-41A8-85FF-04D90BF831D3}" type="datetime3">
               <a:rPr lang="en-US" smtClean="0"/>
-              <a:t>28 May 2026</a:t>
+              <a:t>4 June 2026</a:t>
             </a:fld>
             <a:endParaRPr lang="en-US"/>
           </a:p>
@@ -25897,7 +25897,7 @@
           <a:p>
             <a:fld id="{334F72C3-CDF3-44A8-B602-1649B1728485}" type="datetime3">
               <a:rPr lang="en-US" smtClean="0"/>
-              <a:t>28 May 2026</a:t>
+              <a:t>4 June 2026</a:t>
             </a:fld>
             <a:endParaRPr lang="en-US"/>
           </a:p>
@@ -26204,7 +26204,7 @@
           <a:p>
             <a:fld id="{1E0132BA-B5E7-4FFD-AF6C-169169D47D4A}" type="datetime3">
               <a:rPr lang="en-US" smtClean="0"/>
-              <a:t>28 May 2026</a:t>
+              <a:t>4 June 2026</a:t>
             </a:fld>
             <a:endParaRPr lang="en-US"/>
           </a:p>
@@ -26685,7 +26685,7 @@
           <a:p>
             <a:fld id="{81A30091-1C2A-4151-8D3C-D1E47A72615F}" type="datetime3">
               <a:rPr lang="en-US" smtClean="0"/>
-              <a:t>28 May 2026</a:t>
+              <a:t>4 June 2026</a:t>
             </a:fld>
             <a:endParaRPr lang="en-US"/>
           </a:p>
@@ -27322,7 +27322,7 @@
           <a:p>
             <a:fld id="{35D703CE-07B4-4C05-A488-B4566700621F}" type="datetime3">
               <a:rPr lang="en-US" smtClean="0"/>
-              <a:t>28 May 2026</a:t>
+              <a:t>4 June 2026</a:t>
             </a:fld>
             <a:endParaRPr lang="en-US"/>
           </a:p>
@@ -28380,7 +28380,7 @@
           <a:p>
             <a:fld id="{694BD61C-20BA-43AF-A21F-1DAFB3200099}" type="datetime3">
               <a:rPr lang="en-US" smtClean="0"/>
-              <a:t>28 May 2026</a:t>
+              <a:t>4 June 2026</a:t>
             </a:fld>
             <a:endParaRPr lang="en-US"/>
           </a:p>
@@ -28867,7 +28867,7 @@
           <a:p>
             <a:fld id="{CABCB1B0-B6E5-4DD1-BB55-95C076D6C0C8}" type="datetime3">
               <a:rPr lang="en-US" smtClean="0"/>
-              <a:t>28 May 2026</a:t>
+              <a:t>4 June 2026</a:t>
             </a:fld>
             <a:endParaRPr lang="en-US"/>
           </a:p>
@@ -29394,10 +29394,10 @@
       </p:grpSpPr>
       <p:sp>
         <p:nvSpPr>
-          <p:cNvPr id="3" name="Text Placeholder 2">
+          <p:cNvPr id="16" name="Text Placeholder 15">
             <a:extLst>
               <a:ext uri="{FF2B5EF4-FFF2-40B4-BE49-F238E27FC236}">
-                <a16:creationId xmlns:a16="http://schemas.microsoft.com/office/drawing/2014/main" id="{4B4AD2E4-9301-E47C-2FFF-7AA73A34FD13}"/>
+                <a16:creationId xmlns:a16="http://schemas.microsoft.com/office/drawing/2014/main" id="{18FF48C0-9750-4D6E-5860-4DC5EDB8F830}"/>
               </a:ext>
             </a:extLst>
           </p:cNvPr>
@@ -29419,10 +29419,10 @@
       </p:sp>
       <p:sp>
         <p:nvSpPr>
-          <p:cNvPr id="4" name="Text Placeholder 3">
+          <p:cNvPr id="17" name="Text Placeholder 16">
             <a:extLst>
               <a:ext uri="{FF2B5EF4-FFF2-40B4-BE49-F238E27FC236}">
-                <a16:creationId xmlns:a16="http://schemas.microsoft.com/office/drawing/2014/main" id="{66BBF4E1-D374-B1FA-12F6-F8F0A4B67433}"/>
+                <a16:creationId xmlns:a16="http://schemas.microsoft.com/office/drawing/2014/main" id="{B002F1D5-C4ED-CB9C-9FAC-48F5ACA79610}"/>
               </a:ext>
             </a:extLst>
           </p:cNvPr>
@@ -29444,10 +29444,10 @@
       </p:sp>
       <p:sp>
         <p:nvSpPr>
-          <p:cNvPr id="5" name="Text Placeholder 4">
+          <p:cNvPr id="18" name="Text Placeholder 17">
             <a:extLst>
               <a:ext uri="{FF2B5EF4-FFF2-40B4-BE49-F238E27FC236}">
-                <a16:creationId xmlns:a16="http://schemas.microsoft.com/office/drawing/2014/main" id="{7A879AF6-8779-B2DF-2D6D-B5674BD60B7B}"/>
+                <a16:creationId xmlns:a16="http://schemas.microsoft.com/office/drawing/2014/main" id="{FAF5866C-9F25-3D80-C56F-B57A28B4B001}"/>
               </a:ext>
             </a:extLst>
           </p:cNvPr>
@@ -29469,10 +29469,10 @@
       </p:sp>
       <p:sp>
         <p:nvSpPr>
-          <p:cNvPr id="6" name="Text Placeholder 5">
+          <p:cNvPr id="19" name="Text Placeholder 18">
             <a:extLst>
               <a:ext uri="{FF2B5EF4-FFF2-40B4-BE49-F238E27FC236}">
-                <a16:creationId xmlns:a16="http://schemas.microsoft.com/office/drawing/2014/main" id="{13408D75-45DE-167A-BB68-E3C105A1C2E4}"/>
+                <a16:creationId xmlns:a16="http://schemas.microsoft.com/office/drawing/2014/main" id="{14E4A1B5-4407-DC72-984A-3E4D41D46F7E}"/>
               </a:ext>
             </a:extLst>
           </p:cNvPr>
@@ -29494,10 +29494,10 @@
       </p:sp>
       <p:sp>
         <p:nvSpPr>
-          <p:cNvPr id="7" name="Text Placeholder 6">
+          <p:cNvPr id="20" name="Text Placeholder 19">
             <a:extLst>
               <a:ext uri="{FF2B5EF4-FFF2-40B4-BE49-F238E27FC236}">
-                <a16:creationId xmlns:a16="http://schemas.microsoft.com/office/drawing/2014/main" id="{24FAF86C-ED1A-B6F8-DFA4-D4AE998D2A14}"/>
+                <a16:creationId xmlns:a16="http://schemas.microsoft.com/office/drawing/2014/main" id="{8971EA5A-47D3-99A3-3A6B-71F941D771D6}"/>
               </a:ext>
             </a:extLst>
           </p:cNvPr>
@@ -29519,10 +29519,10 @@
       </p:sp>
       <p:sp>
         <p:nvSpPr>
-          <p:cNvPr id="8" name="Text Placeholder 7">
+          <p:cNvPr id="21" name="Text Placeholder 20">
             <a:extLst>
               <a:ext uri="{FF2B5EF4-FFF2-40B4-BE49-F238E27FC236}">
-                <a16:creationId xmlns:a16="http://schemas.microsoft.com/office/drawing/2014/main" id="{2F126D05-AB19-C9FC-D505-DDCC03EEE12D}"/>
+                <a16:creationId xmlns:a16="http://schemas.microsoft.com/office/drawing/2014/main" id="{7115B789-077D-D626-01EF-9406D5A22B4C}"/>
               </a:ext>
             </a:extLst>
           </p:cNvPr>
@@ -29544,10 +29544,10 @@
       </p:sp>
       <p:sp>
         <p:nvSpPr>
-          <p:cNvPr id="9" name="Text Placeholder 8">
+          <p:cNvPr id="22" name="Text Placeholder 21">
             <a:extLst>
               <a:ext uri="{FF2B5EF4-FFF2-40B4-BE49-F238E27FC236}">
-                <a16:creationId xmlns:a16="http://schemas.microsoft.com/office/drawing/2014/main" id="{2F5EAA87-9A59-CAB2-64CF-7780225CCD85}"/>
+                <a16:creationId xmlns:a16="http://schemas.microsoft.com/office/drawing/2014/main" id="{9E44AF09-B51C-9FA2-1D18-1E263699B95F}"/>
               </a:ext>
             </a:extLst>
           </p:cNvPr>
@@ -29569,10 +29569,10 @@
       </p:sp>
       <p:sp>
         <p:nvSpPr>
-          <p:cNvPr id="10" name="Text Placeholder 9">
+          <p:cNvPr id="23" name="Text Placeholder 22">
             <a:extLst>
               <a:ext uri="{FF2B5EF4-FFF2-40B4-BE49-F238E27FC236}">
-                <a16:creationId xmlns:a16="http://schemas.microsoft.com/office/drawing/2014/main" id="{2B42659D-04AC-59CB-014A-C6DB1A78E6D4}"/>
+                <a16:creationId xmlns:a16="http://schemas.microsoft.com/office/drawing/2014/main" id="{DECC310F-8B65-5F92-0786-EBF1B1C16BA6}"/>
               </a:ext>
             </a:extLst>
           </p:cNvPr>
@@ -29594,10 +29594,10 @@
       </p:sp>
       <p:sp>
         <p:nvSpPr>
-          <p:cNvPr id="11" name="Text Placeholder 10">
+          <p:cNvPr id="24" name="Text Placeholder 23">
             <a:extLst>
               <a:ext uri="{FF2B5EF4-FFF2-40B4-BE49-F238E27FC236}">
-                <a16:creationId xmlns:a16="http://schemas.microsoft.com/office/drawing/2014/main" id="{EB80F884-8C53-C423-CEBF-6EE557DC1DE0}"/>
+                <a16:creationId xmlns:a16="http://schemas.microsoft.com/office/drawing/2014/main" id="{82F5A7D8-D815-1784-7C5D-39734DF38B7D}"/>
               </a:ext>
             </a:extLst>
           </p:cNvPr>
@@ -29619,10 +29619,10 @@
       </p:sp>
       <p:sp>
         <p:nvSpPr>
-          <p:cNvPr id="12" name="Text Placeholder 11">
+          <p:cNvPr id="25" name="Text Placeholder 24">
             <a:extLst>
               <a:ext uri="{FF2B5EF4-FFF2-40B4-BE49-F238E27FC236}">
-                <a16:creationId xmlns:a16="http://schemas.microsoft.com/office/drawing/2014/main" id="{10504F6D-DC1F-0F43-DE2A-E25EF6597063}"/>
+                <a16:creationId xmlns:a16="http://schemas.microsoft.com/office/drawing/2014/main" id="{65F458A7-9133-CD4B-916B-188790E6CD26}"/>
               </a:ext>
             </a:extLst>
           </p:cNvPr>
@@ -29653,9 +29653,10 @@
           </p:nvPr>
         </p:nvSpPr>
         <p:spPr>
-          <a:prstGeom prst="rect">
-            <a:avLst/>
-          </a:prstGeom>
+          <a:xfrm>
+            <a:off x="914401" y="2202820"/>
+            <a:ext cx="6429375" cy="1325880"/>
+          </a:xfrm>
           <a:noFill/>
           <a:ln>
             <a:noFill/>
@@ -29667,28 +29668,11 @@
           </a:bodyPr>
           <a:lstStyle/>
           <a:p>
-            <a:pPr marL="0" lvl="0" indent="0" algn="ctr" rtl="0">
-              <a:lnSpc>
-                <a:spcPct val="90000"/>
-              </a:lnSpc>
-              <a:spcBef>
-                <a:spcPts val="0"/>
-              </a:spcBef>
-              <a:spcAft>
-                <a:spcPts val="0"/>
-              </a:spcAft>
-              <a:buClr>
-                <a:schemeClr val="dk1"/>
-              </a:buClr>
-              <a:buSzPts val="6000"/>
-              <a:buFont typeface="Play"/>
-              <a:buNone/>
-            </a:pPr>
+            <a:pPr lvl="0"/>
             <a:r>
               <a:rPr lang="en-US"/>
               <a:t>Intro to Version Control</a:t>
             </a:r>
-            <a:endParaRPr/>
           </a:p>
         </p:txBody>
       </p:sp>
@@ -29703,9 +29687,10 @@
           </p:nvPr>
         </p:nvSpPr>
         <p:spPr>
-          <a:prstGeom prst="rect">
-            <a:avLst/>
-          </a:prstGeom>
+          <a:xfrm>
+            <a:off x="914402" y="3784732"/>
+            <a:ext cx="3565524" cy="457200"/>
+          </a:xfrm>
           <a:noFill/>
           <a:ln>
             <a:noFill/>
@@ -29717,36 +29702,20 @@
           </a:bodyPr>
           <a:lstStyle/>
           <a:p>
-            <a:pPr marL="0" lvl="0" indent="0" algn="ctr" rtl="0">
-              <a:lnSpc>
-                <a:spcPct val="90000"/>
-              </a:lnSpc>
-              <a:spcBef>
-                <a:spcPts val="0"/>
-              </a:spcBef>
-              <a:spcAft>
-                <a:spcPts val="0"/>
-              </a:spcAft>
-              <a:buClr>
-                <a:schemeClr val="dk1"/>
-              </a:buClr>
-              <a:buSzPts val="2400"/>
-              <a:buNone/>
-            </a:pPr>
+            <a:pPr lvl="0"/>
             <a:r>
               <a:rPr lang="en-US"/>
               <a:t>AI2C Tech Intro</a:t>
             </a:r>
-            <a:endParaRPr/>
           </a:p>
         </p:txBody>
       </p:sp>
       <p:sp>
         <p:nvSpPr>
-          <p:cNvPr id="2" name="Text Placeholder 1">
+          <p:cNvPr id="15" name="Text Placeholder 14">
             <a:extLst>
               <a:ext uri="{FF2B5EF4-FFF2-40B4-BE49-F238E27FC236}">
-                <a16:creationId xmlns:a16="http://schemas.microsoft.com/office/drawing/2014/main" id="{4C72C60C-0A05-CE76-AFDB-3ADE550735B1}"/>
+                <a16:creationId xmlns:a16="http://schemas.microsoft.com/office/drawing/2014/main" id="{D934CD16-F3A4-FE1C-B9B0-FAB60720CFA6}"/>
               </a:ext>
             </a:extLst>
           </p:cNvPr>
@@ -29853,7 +29822,7 @@
           <a:p>
             <a:fld id="{AD622D1A-DF83-41A8-85FF-04D90BF831D3}" type="datetime3">
               <a:rPr lang="en-US" smtClean="0"/>
-              <a:t>28 May 2026</a:t>
+              <a:t>4 June 2026</a:t>
             </a:fld>
             <a:endParaRPr lang="en-US"/>
           </a:p>
@@ -33561,7 +33530,7 @@
           <a:p>
             <a:fld id="{AD622D1A-DF83-41A8-85FF-04D90BF831D3}" type="datetime3">
               <a:rPr lang="en-US" smtClean="0"/>
-              <a:t>28 May 2026</a:t>
+              <a:t>4 June 2026</a:t>
             </a:fld>
             <a:endParaRPr lang="en-US"/>
           </a:p>
@@ -40241,7 +40210,7 @@
           <a:p>
             <a:fld id="{AD622D1A-DF83-41A8-85FF-04D90BF831D3}" type="datetime3">
               <a:rPr lang="en-US" smtClean="0"/>
-              <a:t>28 May 2026</a:t>
+              <a:t>4 June 2026</a:t>
             </a:fld>
             <a:endParaRPr lang="en-US"/>
           </a:p>
@@ -47005,7 +46974,7 @@
           <a:p>
             <a:fld id="{AD622D1A-DF83-41A8-85FF-04D90BF831D3}" type="datetime3">
               <a:rPr lang="en-US" smtClean="0"/>
-              <a:t>28 May 2026</a:t>
+              <a:t>4 June 2026</a:t>
             </a:fld>
             <a:endParaRPr lang="en-US"/>
           </a:p>
@@ -49544,7 +49513,7 @@
           <a:p>
             <a:fld id="{AD622D1A-DF83-41A8-85FF-04D90BF831D3}" type="datetime3">
               <a:rPr lang="en-US" smtClean="0"/>
-              <a:t>28 May 2026</a:t>
+              <a:t>4 June 2026</a:t>
             </a:fld>
             <a:endParaRPr lang="en-US"/>
           </a:p>
@@ -50886,7 +50855,7 @@
           <a:p>
             <a:fld id="{AD622D1A-DF83-41A8-85FF-04D90BF831D3}" type="datetime3">
               <a:rPr lang="en-US" smtClean="0"/>
-              <a:t>28 May 2026</a:t>
+              <a:t>4 June 2026</a:t>
             </a:fld>
             <a:endParaRPr lang="en-US"/>
           </a:p>

</xml_diff>